<commit_message>
fix: give slide 1 fields room for wrapped problem-statement title
</commit_message>
<xml_diff>
--- a/docs/presentation/RaahSetu-SIH2026.pptx
+++ b/docs/presentation/RaahSetu-SIH2026.pptx
@@ -1451,7 +1451,7 @@
         </p:nvSpPr>
         <p:spPr>
           <a:xfrm>
-            <a:off x="502920" y="2286000"/>
+            <a:off x="502920" y="2240280"/>
             <a:ext cx="5120640" cy="868680"/>
           </a:xfrm>
           <a:prstGeom prst="rect">
@@ -1490,8 +1490,8 @@
         </p:nvSpPr>
         <p:spPr>
           <a:xfrm>
-            <a:off x="502920" y="3310128"/>
-            <a:ext cx="2148840" cy="365760"/>
+            <a:off x="502920" y="3200400"/>
+            <a:ext cx="2148840" cy="384048"/>
           </a:xfrm>
           <a:prstGeom prst="rect">
             <a:avLst/>
@@ -1529,8 +1529,8 @@
         </p:nvSpPr>
         <p:spPr>
           <a:xfrm>
-            <a:off x="2743200" y="3310128"/>
-            <a:ext cx="3063240" cy="365760"/>
+            <a:off x="2743200" y="3200400"/>
+            <a:ext cx="3063240" cy="384048"/>
           </a:xfrm>
           <a:prstGeom prst="rect">
             <a:avLst/>
@@ -1568,8 +1568,8 @@
         </p:nvSpPr>
         <p:spPr>
           <a:xfrm>
-            <a:off x="502920" y="3767328"/>
-            <a:ext cx="2148840" cy="603504"/>
+            <a:off x="502920" y="3694176"/>
+            <a:ext cx="2148840" cy="777240"/>
           </a:xfrm>
           <a:prstGeom prst="rect">
             <a:avLst/>
@@ -1607,8 +1607,8 @@
         </p:nvSpPr>
         <p:spPr>
           <a:xfrm>
-            <a:off x="2743200" y="3767328"/>
-            <a:ext cx="3063240" cy="603504"/>
+            <a:off x="2743200" y="3694176"/>
+            <a:ext cx="3063240" cy="777240"/>
           </a:xfrm>
           <a:prstGeom prst="rect">
             <a:avLst/>
@@ -1646,8 +1646,8 @@
         </p:nvSpPr>
         <p:spPr>
           <a:xfrm>
-            <a:off x="502920" y="4462272"/>
-            <a:ext cx="2148840" cy="365760"/>
+            <a:off x="502920" y="4581144"/>
+            <a:ext cx="2148840" cy="384048"/>
           </a:xfrm>
           <a:prstGeom prst="rect">
             <a:avLst/>
@@ -1685,8 +1685,8 @@
         </p:nvSpPr>
         <p:spPr>
           <a:xfrm>
-            <a:off x="2743200" y="4462272"/>
-            <a:ext cx="3063240" cy="365760"/>
+            <a:off x="2743200" y="4581144"/>
+            <a:ext cx="3063240" cy="384048"/>
           </a:xfrm>
           <a:prstGeom prst="rect">
             <a:avLst/>
@@ -1724,8 +1724,8 @@
         </p:nvSpPr>
         <p:spPr>
           <a:xfrm>
-            <a:off x="502920" y="4919472"/>
-            <a:ext cx="2148840" cy="365760"/>
+            <a:off x="502920" y="5074920"/>
+            <a:ext cx="2148840" cy="384048"/>
           </a:xfrm>
           <a:prstGeom prst="rect">
             <a:avLst/>
@@ -1763,8 +1763,8 @@
         </p:nvSpPr>
         <p:spPr>
           <a:xfrm>
-            <a:off x="2743200" y="4919472"/>
-            <a:ext cx="3063240" cy="365760"/>
+            <a:off x="2743200" y="5074920"/>
+            <a:ext cx="3063240" cy="384048"/>
           </a:xfrm>
           <a:prstGeom prst="rect">
             <a:avLst/>
@@ -1802,8 +1802,8 @@
         </p:nvSpPr>
         <p:spPr>
           <a:xfrm>
-            <a:off x="502920" y="5376672"/>
-            <a:ext cx="2148840" cy="365760"/>
+            <a:off x="502920" y="5568696"/>
+            <a:ext cx="2148840" cy="384048"/>
           </a:xfrm>
           <a:prstGeom prst="rect">
             <a:avLst/>
@@ -1841,8 +1841,8 @@
         </p:nvSpPr>
         <p:spPr>
           <a:xfrm>
-            <a:off x="2743200" y="5376672"/>
-            <a:ext cx="3063240" cy="365760"/>
+            <a:off x="2743200" y="5568696"/>
+            <a:ext cx="3063240" cy="384048"/>
           </a:xfrm>
           <a:prstGeom prst="rect">
             <a:avLst/>
@@ -1880,8 +1880,8 @@
         </p:nvSpPr>
         <p:spPr>
           <a:xfrm>
-            <a:off x="502920" y="5833872"/>
-            <a:ext cx="2148840" cy="365760"/>
+            <a:off x="502920" y="6062472"/>
+            <a:ext cx="2148840" cy="384048"/>
           </a:xfrm>
           <a:prstGeom prst="rect">
             <a:avLst/>
@@ -1919,8 +1919,8 @@
         </p:nvSpPr>
         <p:spPr>
           <a:xfrm>
-            <a:off x="2743200" y="5833872"/>
-            <a:ext cx="3063240" cy="365760"/>
+            <a:off x="2743200" y="6062472"/>
+            <a:ext cx="3063240" cy="384048"/>
           </a:xfrm>
           <a:prstGeom prst="rect">
             <a:avLst/>

</xml_diff>